<commit_message>
Stage 8 review fixes: B-036
</commit_message>
<xml_diff>
--- a/output/archive/BrindlewytheData/QA/Training/2024/Copy of Sample_handover_training.pptx
+++ b/output/archive/BrindlewytheData/QA/Training/2024/Copy of Sample_handover_training.pptx
@@ -3788,7 +3788,7 @@
               <a:rPr sz="1700">
                 <a:latin typeface="Arial"/>
               </a:rPr>
-              <a:t>A card with a missing field goes back to the sender before storage</a:t>
+              <a:t>Record missing fields, seek clarification and hold release; place the sample in appropriate controlled storage</a:t>
             </a:r>
           </a:p>
           <a:p>
@@ -4002,7 +4002,7 @@
               <a:rPr sz="2000">
                 <a:latin typeface="Arial"/>
               </a:rPr>
-              <a:t>Store at the stated temperature within the hour</a:t>
+              <a:t>Store promptly under the specified conditions; record receipt and storage times</a:t>
             </a:r>
           </a:p>
         </p:txBody>
@@ -4709,7 +4709,7 @@
               <a:rPr sz="2000">
                 <a:latin typeface="Arial"/>
               </a:rPr>
-              <a:t>Vials go to the store only after the card is signed</a:t>
+              <a:t>Place vials in appropriate controlled storage while receipt discrepancies are resolved</a:t>
             </a:r>
           </a:p>
           <a:p>
@@ -4928,7 +4928,7 @@
               <a:rPr sz="1800">
                 <a:latin typeface="Arial"/>
               </a:rPr>
-              <a:t>Hold the vial and the card together</a:t>
+              <a:t>Hold release and keep the vial linked to its sample card</a:t>
             </a:r>
           </a:p>
           <a:p>
@@ -4937,7 +4937,7 @@
               <a:rPr sz="1800">
                 <a:latin typeface="Arial"/>
               </a:rPr>
-              <a:t>Call the sample management coordinator before moving anything</a:t>
+              <a:t>Notify the sample management coordinator; record any transfer needed to protect the sample</a:t>
             </a:r>
           </a:p>
         </p:txBody>

</xml_diff>